<commit_message>
Update projet_final.pptx and image project added
</commit_message>
<xml_diff>
--- a/Docs/Projet_final.pptx
+++ b/Docs/Projet_final.pptx
@@ -6,10 +6,10 @@
     <p:sldMasterId id="2147483660" r:id="rId5"/>
   </p:sldMasterIdLst>
   <p:notesMasterIdLst>
-    <p:notesMasterId r:id="rId18"/>
+    <p:notesMasterId r:id="rId19"/>
   </p:notesMasterIdLst>
   <p:handoutMasterIdLst>
-    <p:handoutMasterId r:id="rId19"/>
+    <p:handoutMasterId r:id="rId20"/>
   </p:handoutMasterIdLst>
   <p:sldIdLst>
     <p:sldId id="256" r:id="rId6"/>
@@ -24,6 +24,7 @@
     <p:sldId id="311" r:id="rId15"/>
     <p:sldId id="312" r:id="rId16"/>
     <p:sldId id="313" r:id="rId17"/>
+    <p:sldId id="319" r:id="rId18"/>
   </p:sldIdLst>
   <p:sldSz cx="12192000" cy="6858000"/>
   <p:notesSz cx="6858000" cy="9144000"/>
@@ -757,6 +758,114 @@
     <p:extLst>
       <p:ext uri="{BB962C8B-B14F-4D97-AF65-F5344CB8AC3E}">
         <p14:creationId xmlns:p14="http://schemas.microsoft.com/office/powerpoint/2010/main" val="2987470732"/>
+      </p:ext>
+    </p:extLst>
+  </p:cSld>
+  <p:clrMapOvr>
+    <a:masterClrMapping/>
+  </p:clrMapOvr>
+</p:notes>
+</file>
+
+<file path=ppt/notesSlides/notesSlide2.xml><?xml version="1.0" encoding="utf-8"?>
+<p:notes xmlns:a="http://schemas.openxmlformats.org/drawingml/2006/main" xmlns:r="http://schemas.openxmlformats.org/officeDocument/2006/relationships" xmlns:p="http://schemas.openxmlformats.org/presentationml/2006/main">
+  <p:cSld>
+    <p:spTree>
+      <p:nvGrpSpPr>
+        <p:cNvPr id="1" name="">
+          <a:extLst>
+            <a:ext uri="{FF2B5EF4-FFF2-40B4-BE49-F238E27FC236}">
+              <a16:creationId xmlns:a16="http://schemas.microsoft.com/office/drawing/2014/main" id="{4D2694A6-0FEE-2114-A016-8204F8B9DED8}"/>
+            </a:ext>
+          </a:extLst>
+        </p:cNvPr>
+        <p:cNvGrpSpPr/>
+        <p:nvPr/>
+      </p:nvGrpSpPr>
+      <p:grpSpPr>
+        <a:xfrm>
+          <a:off x="0" y="0"/>
+          <a:ext cx="0" cy="0"/>
+          <a:chOff x="0" y="0"/>
+          <a:chExt cx="0" cy="0"/>
+        </a:xfrm>
+      </p:grpSpPr>
+      <p:sp>
+        <p:nvSpPr>
+          <p:cNvPr id="2" name="Espace réservé de l'image des diapositives 1">
+            <a:extLst>
+              <a:ext uri="{FF2B5EF4-FFF2-40B4-BE49-F238E27FC236}">
+                <a16:creationId xmlns:a16="http://schemas.microsoft.com/office/drawing/2014/main" id="{B7A2A262-BE67-3BF7-91F7-E3B6E6CAEFD4}"/>
+              </a:ext>
+            </a:extLst>
+          </p:cNvPr>
+          <p:cNvSpPr>
+            <a:spLocks noGrp="1" noRot="1" noChangeAspect="1"/>
+          </p:cNvSpPr>
+          <p:nvPr>
+            <p:ph type="sldImg"/>
+          </p:nvPr>
+        </p:nvSpPr>
+        <p:spPr/>
+      </p:sp>
+      <p:sp>
+        <p:nvSpPr>
+          <p:cNvPr id="3" name="Espace réservé des notes 2">
+            <a:extLst>
+              <a:ext uri="{FF2B5EF4-FFF2-40B4-BE49-F238E27FC236}">
+                <a16:creationId xmlns:a16="http://schemas.microsoft.com/office/drawing/2014/main" id="{5D835B24-FB12-AD54-B5D2-A21FC6082F64}"/>
+              </a:ext>
+            </a:extLst>
+          </p:cNvPr>
+          <p:cNvSpPr>
+            <a:spLocks noGrp="1"/>
+          </p:cNvSpPr>
+          <p:nvPr>
+            <p:ph type="body" idx="1"/>
+          </p:nvPr>
+        </p:nvSpPr>
+        <p:spPr/>
+        <p:txBody>
+          <a:bodyPr/>
+          <a:lstStyle/>
+          <a:p>
+            <a:endParaRPr lang="fr-FR" dirty="0"/>
+          </a:p>
+        </p:txBody>
+      </p:sp>
+      <p:sp>
+        <p:nvSpPr>
+          <p:cNvPr id="4" name="Espace réservé du numéro de diapositive 3">
+            <a:extLst>
+              <a:ext uri="{FF2B5EF4-FFF2-40B4-BE49-F238E27FC236}">
+                <a16:creationId xmlns:a16="http://schemas.microsoft.com/office/drawing/2014/main" id="{F6835263-0B50-C8B6-3D39-EC58FDE637BB}"/>
+              </a:ext>
+            </a:extLst>
+          </p:cNvPr>
+          <p:cNvSpPr>
+            <a:spLocks noGrp="1"/>
+          </p:cNvSpPr>
+          <p:nvPr>
+            <p:ph type="sldNum" sz="quarter" idx="5"/>
+          </p:nvPr>
+        </p:nvSpPr>
+        <p:spPr/>
+        <p:txBody>
+          <a:bodyPr/>
+          <a:lstStyle/>
+          <a:p>
+            <a:fld id="{3E1BF473-EC16-4647-BA3C-CDFDC5577E6A}" type="slidenum">
+              <a:rPr lang="fr-FR" smtClean="0"/>
+              <a:t>13</a:t>
+            </a:fld>
+            <a:endParaRPr lang="fr-FR"/>
+          </a:p>
+        </p:txBody>
+      </p:sp>
+    </p:spTree>
+    <p:extLst>
+      <p:ext uri="{BB962C8B-B14F-4D97-AF65-F5344CB8AC3E}">
+        <p14:creationId xmlns:p14="http://schemas.microsoft.com/office/powerpoint/2010/main" val="1527612580"/>
       </p:ext>
     </p:extLst>
   </p:cSld>
@@ -4689,10 +4798,212 @@
           </a:p>
         </p:txBody>
       </p:sp>
+      <p:pic>
+        <p:nvPicPr>
+          <p:cNvPr id="2" name="Image 1" descr="Une image contenant Ingénierie électronique, câble, fils électriques, Composant électronique&#10;&#10;Le contenu généré par l’IA peut être incorrect.">
+            <a:extLst>
+              <a:ext uri="{FF2B5EF4-FFF2-40B4-BE49-F238E27FC236}">
+                <a16:creationId xmlns:a16="http://schemas.microsoft.com/office/drawing/2014/main" id="{772F2D22-BC8B-A822-63E8-853AA2AB4EDF}"/>
+              </a:ext>
+            </a:extLst>
+          </p:cNvPr>
+          <p:cNvPicPr>
+            <a:picLocks noChangeAspect="1"/>
+          </p:cNvPicPr>
+          <p:nvPr/>
+        </p:nvPicPr>
+        <p:blipFill>
+          <a:blip r:embed="rId2">
+            <a:extLst>
+              <a:ext uri="{28A0092B-C50C-407E-A947-70E740481C1C}">
+                <a14:useLocalDpi xmlns:a14="http://schemas.microsoft.com/office/drawing/2010/main" val="0"/>
+              </a:ext>
+            </a:extLst>
+          </a:blip>
+          <a:stretch>
+            <a:fillRect/>
+          </a:stretch>
+        </p:blipFill>
+        <p:spPr>
+          <a:xfrm rot="16200000">
+            <a:off x="7109281" y="996772"/>
+            <a:ext cx="3752099" cy="4997592"/>
+          </a:xfrm>
+          <a:prstGeom prst="rect">
+            <a:avLst/>
+          </a:prstGeom>
+        </p:spPr>
+      </p:pic>
     </p:spTree>
     <p:extLst>
       <p:ext uri="{BB962C8B-B14F-4D97-AF65-F5344CB8AC3E}">
         <p14:creationId xmlns:p14="http://schemas.microsoft.com/office/powerpoint/2010/main" val="1390509475"/>
+      </p:ext>
+    </p:extLst>
+  </p:cSld>
+  <p:clrMapOvr>
+    <a:masterClrMapping/>
+  </p:clrMapOvr>
+</p:sld>
+</file>
+
+<file path=ppt/slides/slide13.xml><?xml version="1.0" encoding="utf-8"?>
+<p:sld xmlns:a="http://schemas.openxmlformats.org/drawingml/2006/main" xmlns:r="http://schemas.openxmlformats.org/officeDocument/2006/relationships" xmlns:p="http://schemas.openxmlformats.org/presentationml/2006/main">
+  <p:cSld>
+    <p:spTree>
+      <p:nvGrpSpPr>
+        <p:cNvPr id="1" name="">
+          <a:extLst>
+            <a:ext uri="{FF2B5EF4-FFF2-40B4-BE49-F238E27FC236}">
+              <a16:creationId xmlns:a16="http://schemas.microsoft.com/office/drawing/2014/main" id="{0E22EAFC-7A16-7EA0-10F4-38AEFC620D1B}"/>
+            </a:ext>
+          </a:extLst>
+        </p:cNvPr>
+        <p:cNvGrpSpPr/>
+        <p:nvPr/>
+      </p:nvGrpSpPr>
+      <p:grpSpPr>
+        <a:xfrm>
+          <a:off x="0" y="0"/>
+          <a:ext cx="0" cy="0"/>
+          <a:chOff x="0" y="0"/>
+          <a:chExt cx="0" cy="0"/>
+        </a:xfrm>
+      </p:grpSpPr>
+      <p:pic>
+        <p:nvPicPr>
+          <p:cNvPr id="8" name="Image 7" descr="Une image contenant capture d’écran, art, Graphique, bleu vert&#10;&#10;Le contenu généré par l’IA peut être incorrect.">
+            <a:extLst>
+              <a:ext uri="{FF2B5EF4-FFF2-40B4-BE49-F238E27FC236}">
+                <a16:creationId xmlns:a16="http://schemas.microsoft.com/office/drawing/2014/main" id="{B04E8CA1-674F-848A-D750-0821B35EBEAA}"/>
+              </a:ext>
+            </a:extLst>
+          </p:cNvPr>
+          <p:cNvPicPr>
+            <a:picLocks noChangeAspect="1"/>
+          </p:cNvPicPr>
+          <p:nvPr/>
+        </p:nvPicPr>
+        <p:blipFill>
+          <a:blip r:embed="rId3">
+            <a:extLst>
+              <a:ext uri="{28A0092B-C50C-407E-A947-70E740481C1C}">
+                <a14:useLocalDpi xmlns:a14="http://schemas.microsoft.com/office/drawing/2010/main" val="0"/>
+              </a:ext>
+            </a:extLst>
+          </a:blip>
+          <a:stretch>
+            <a:fillRect/>
+          </a:stretch>
+        </p:blipFill>
+        <p:spPr>
+          <a:xfrm>
+            <a:off x="6807112" y="0"/>
+            <a:ext cx="5384888" cy="6302523"/>
+          </a:xfrm>
+          <a:prstGeom prst="rect">
+            <a:avLst/>
+          </a:prstGeom>
+        </p:spPr>
+      </p:pic>
+      <p:sp>
+        <p:nvSpPr>
+          <p:cNvPr id="12" name="Titre 2">
+            <a:extLst>
+              <a:ext uri="{FF2B5EF4-FFF2-40B4-BE49-F238E27FC236}">
+                <a16:creationId xmlns:a16="http://schemas.microsoft.com/office/drawing/2014/main" id="{34A20E6D-C7FB-890B-37D8-C3DACB27B1B3}"/>
+              </a:ext>
+            </a:extLst>
+          </p:cNvPr>
+          <p:cNvSpPr txBox="1">
+            <a:spLocks/>
+          </p:cNvSpPr>
+          <p:nvPr/>
+        </p:nvSpPr>
+        <p:spPr>
+          <a:xfrm>
+            <a:off x="134306" y="2478274"/>
+            <a:ext cx="6672806" cy="646331"/>
+          </a:xfrm>
+          <a:prstGeom prst="rect">
+            <a:avLst/>
+          </a:prstGeom>
+          <a:solidFill>
+            <a:schemeClr val="bg1"/>
+          </a:solidFill>
+        </p:spPr>
+        <p:txBody>
+          <a:bodyPr anchor="ctr" anchorCtr="0">
+            <a:normAutofit/>
+          </a:bodyPr>
+          <a:lstStyle>
+            <a:lvl1pPr algn="r" defTabSz="914400" rtl="0" eaLnBrk="1" latinLnBrk="0" hangingPunct="1">
+              <a:lnSpc>
+                <a:spcPct val="90000"/>
+              </a:lnSpc>
+              <a:spcBef>
+                <a:spcPct val="0"/>
+              </a:spcBef>
+              <a:buNone/>
+              <a:defRPr sz="3200" b="1" kern="1200">
+                <a:solidFill>
+                  <a:schemeClr val="tx1"/>
+                </a:solidFill>
+                <a:latin typeface="Tenorite" panose="00000500000000000000" pitchFamily="2" charset="0"/>
+                <a:ea typeface="+mj-ea"/>
+                <a:cs typeface="Arial" panose="020B0604020202020204" pitchFamily="34" charset="0"/>
+              </a:defRPr>
+            </a:lvl1pPr>
+          </a:lstStyle>
+          <a:p>
+            <a:r>
+              <a:rPr lang="en-US" dirty="0"/>
+              <a:t>THANK YOU FOR YOUR ATTENTION</a:t>
+            </a:r>
+            <a:endParaRPr lang="fr-FR" dirty="0"/>
+          </a:p>
+        </p:txBody>
+      </p:sp>
+      <p:sp>
+        <p:nvSpPr>
+          <p:cNvPr id="13" name="Sous-titre 3">
+            <a:extLst>
+              <a:ext uri="{FF2B5EF4-FFF2-40B4-BE49-F238E27FC236}">
+                <a16:creationId xmlns:a16="http://schemas.microsoft.com/office/drawing/2014/main" id="{1E2F4539-4642-F937-CB0B-4B8FE31BEF62}"/>
+              </a:ext>
+            </a:extLst>
+          </p:cNvPr>
+          <p:cNvSpPr>
+            <a:spLocks noGrp="1"/>
+          </p:cNvSpPr>
+          <p:nvPr>
+            <p:ph type="subTitle" idx="1"/>
+          </p:nvPr>
+        </p:nvSpPr>
+        <p:spPr>
+          <a:xfrm>
+            <a:off x="6484" y="3534988"/>
+            <a:ext cx="3951287" cy="396815"/>
+          </a:xfrm>
+          <a:solidFill>
+            <a:schemeClr val="bg1"/>
+          </a:solidFill>
+        </p:spPr>
+        <p:txBody>
+          <a:bodyPr/>
+          <a:lstStyle/>
+          <a:p>
+            <a:r>
+              <a:rPr lang="en-US" dirty="0"/>
+              <a:t>Feel free to ask any question</a:t>
+            </a:r>
+          </a:p>
+        </p:txBody>
+      </p:sp>
+    </p:spTree>
+    <p:extLst>
+      <p:ext uri="{BB962C8B-B14F-4D97-AF65-F5344CB8AC3E}">
+        <p14:creationId xmlns:p14="http://schemas.microsoft.com/office/powerpoint/2010/main" val="1254972480"/>
       </p:ext>
     </p:extLst>
   </p:cSld>
@@ -7605,6 +7916,42 @@
           </p:txBody>
         </p:sp>
       </p:grpSp>
+      <p:pic>
+        <p:nvPicPr>
+          <p:cNvPr id="3" name="Image 2" descr="Une image contenant Ingénierie électronique, câble, fils électriques, Composant électronique&#10;&#10;Le contenu généré par l’IA peut être incorrect.">
+            <a:extLst>
+              <a:ext uri="{FF2B5EF4-FFF2-40B4-BE49-F238E27FC236}">
+                <a16:creationId xmlns:a16="http://schemas.microsoft.com/office/drawing/2014/main" id="{4E96CF89-A2D1-6F60-DE67-77692B05B995}"/>
+              </a:ext>
+            </a:extLst>
+          </p:cNvPr>
+          <p:cNvPicPr>
+            <a:picLocks noChangeAspect="1"/>
+          </p:cNvPicPr>
+          <p:nvPr/>
+        </p:nvPicPr>
+        <p:blipFill>
+          <a:blip r:embed="rId6">
+            <a:extLst>
+              <a:ext uri="{28A0092B-C50C-407E-A947-70E740481C1C}">
+                <a14:useLocalDpi xmlns:a14="http://schemas.microsoft.com/office/drawing/2010/main" val="0"/>
+              </a:ext>
+            </a:extLst>
+          </a:blip>
+          <a:stretch>
+            <a:fillRect/>
+          </a:stretch>
+        </p:blipFill>
+        <p:spPr>
+          <a:xfrm rot="16200000">
+            <a:off x="7109281" y="996772"/>
+            <a:ext cx="3752099" cy="4997592"/>
+          </a:xfrm>
+          <a:prstGeom prst="rect">
+            <a:avLst/>
+          </a:prstGeom>
+        </p:spPr>
+      </p:pic>
     </p:spTree>
     <p:extLst>
       <p:ext uri="{BB962C8B-B14F-4D97-AF65-F5344CB8AC3E}">
@@ -10453,15 +10800,6 @@
 </file>
 
 <file path=customXml/item1.xml><?xml version="1.0" encoding="utf-8"?>
-<?mso-contentType ?>
-<FormTemplates xmlns="http://schemas.microsoft.com/sharepoint/v3/contenttype/forms">
-  <Display>DocumentLibraryForm</Display>
-  <Edit>DocumentLibraryForm</Edit>
-  <New>DocumentLibraryForm</New>
-</FormTemplates>
-</file>
-
-<file path=customXml/item2.xml><?xml version="1.0" encoding="utf-8"?>
 <ct:contentTypeSchema xmlns:ct="http://schemas.microsoft.com/office/2006/metadata/contentType" xmlns:ma="http://schemas.microsoft.com/office/2006/metadata/properties/metaAttributes" ct:_="" ma:_="" ma:contentTypeName="Document" ma:contentTypeID="0x010100D1DBFDC516FB7D498F2708E0668661F7" ma:contentTypeVersion="15" ma:contentTypeDescription="Create a new document." ma:contentTypeScope="" ma:versionID="76190fd46b8ecc19c259073b19191ac1">
   <xsd:schema xmlns:xsd="http://www.w3.org/2001/XMLSchema" xmlns:xs="http://www.w3.org/2001/XMLSchema" xmlns:p="http://schemas.microsoft.com/office/2006/metadata/properties" xmlns:ns2="fd043017-6145-4171-ae53-4a2444b0f3a8" xmlns:ns3="ae4d9fed-4369-4efa-870f-7c4fbc625802" targetNamespace="http://schemas.microsoft.com/office/2006/metadata/properties" ma:root="true" ma:fieldsID="1923d3a5d954ca530e5d58ea92103f74" ns2:_="" ns3:_="">
     <xsd:import namespace="fd043017-6145-4171-ae53-4a2444b0f3a8"/>
@@ -10696,6 +11034,15 @@
 </ct:contentTypeSchema>
 </file>
 
+<file path=customXml/item2.xml><?xml version="1.0" encoding="utf-8"?>
+<?mso-contentType ?>
+<FormTemplates xmlns="http://schemas.microsoft.com/sharepoint/v3/contenttype/forms">
+  <Display>DocumentLibraryForm</Display>
+  <Edit>DocumentLibraryForm</Edit>
+  <New>DocumentLibraryForm</New>
+</FormTemplates>
+</file>
+
 <file path=customXml/item3.xml><?xml version="1.0" encoding="utf-8"?>
 <p:properties xmlns:p="http://schemas.microsoft.com/office/2006/metadata/properties" xmlns:xsi="http://www.w3.org/2001/XMLSchema-instance" xmlns:pc="http://schemas.microsoft.com/office/infopath/2007/PartnerControls">
   <documentManagement>
@@ -10708,14 +11055,6 @@
 </file>
 
 <file path=customXml/itemProps1.xml><?xml version="1.0" encoding="utf-8"?>
-<ds:datastoreItem xmlns:ds="http://schemas.openxmlformats.org/officeDocument/2006/customXml" ds:itemID="{90619B12-AFF5-4C5C-937B-0A7AB1969000}">
-  <ds:schemaRefs>
-    <ds:schemaRef ds:uri="http://schemas.microsoft.com/sharepoint/v3/contenttype/forms"/>
-  </ds:schemaRefs>
-</ds:datastoreItem>
-</file>
-
-<file path=customXml/itemProps2.xml><?xml version="1.0" encoding="utf-8"?>
 <ds:datastoreItem xmlns:ds="http://schemas.openxmlformats.org/officeDocument/2006/customXml" ds:itemID="{7FEA0324-74CB-4E11-A24D-EE3DF264393B}">
   <ds:schemaRefs>
     <ds:schemaRef ds:uri="http://schemas.microsoft.com/office/2006/metadata/contentType"/>
@@ -10730,6 +11069,14 @@
     <ds:schemaRef ds:uri="http://purl.org/dc/elements/1.1/"/>
     <ds:schemaRef ds:uri="http://purl.org/dc/terms/"/>
     <ds:schemaRef ds:uri="http://schemas.microsoft.com/internal/obd"/>
+  </ds:schemaRefs>
+</ds:datastoreItem>
+</file>
+
+<file path=customXml/itemProps2.xml><?xml version="1.0" encoding="utf-8"?>
+<ds:datastoreItem xmlns:ds="http://schemas.openxmlformats.org/officeDocument/2006/customXml" ds:itemID="{90619B12-AFF5-4C5C-937B-0A7AB1969000}">
+  <ds:schemaRefs>
+    <ds:schemaRef ds:uri="http://schemas.microsoft.com/sharepoint/v3/contenttype/forms"/>
   </ds:schemaRefs>
 </ds:datastoreItem>
 </file>

</xml_diff>